<commit_message>
U3 complete: integrity layer verified on REAL OpenVINS output — IB coverage 97.2% (31k verdicts); measured docs/deck refresh
Same monitor/manager nodes as the live demo, remapped to the container's root-ns topics, recording a CSV verdict during golden-bag playback. Drift reproduced deterministically (0.219%/202.2 m). Deck sheet 8/9 now carry measured numbers; manual rewritten with all-tiers-measured status + three demo rungs; README verified-status table updated. Known cosmetic: nav-state feature thresholds need rescaling for ov points_msckf semantics (noted in results).
</commit_message>
<xml_diff>
--- a/docs/AETHER_DesignAThon_Final.pptx
+++ b/docs/AETHER_DesignAThon_Final.pptx
@@ -12990,7 +12990,7 @@
                 <a:ea typeface="Consolas" pitchFamily="34" charset="-122"/>
                 <a:cs typeface="Consolas" pitchFamily="34" charset="-120"/>
               </a:rPr>
-              <a:t>VERIFIED RUNNING TODAY (no Ubuntu needed)</a:t>
+              <a:t>VERIFIED RUNNING — MEASURED, NOT PROJECTED</a:t>
             </a:r>
             <a:endParaRPr lang="en-US" sz="1000" dirty="0"/>
           </a:p>
@@ -13032,7 +13032,7 @@
                 <a:ea typeface="Consolas" pitchFamily="34" charset="-122"/>
                 <a:cs typeface="Consolas" pitchFamily="34" charset="-120"/>
               </a:rPr>
-              <a:t>$ python offline_demo/verify_constants.py
+              <a:t>LIVE ROS2 integrity stack (Ubuntu 26.04/Lyrical)
 </a:t>
             </a:r>
             <a:endParaRPr lang="en-US" sz="1000" dirty="0"/>
@@ -13053,7 +13053,7 @@
                 <a:ea typeface="Consolas" pitchFamily="34" charset="-122"/>
                 <a:cs typeface="Consolas" pitchFamily="34" charset="-120"/>
               </a:rPr>
-              <a:t>  k_op=2.4477  k_ffd=6.7374  λ_md=44.99  ✓
+              <a:t>  coverage 97.6% · ANEES 3.05 · detect 1.18 s
 </a:t>
             </a:r>
             <a:endParaRPr lang="en-US" sz="1000" dirty="0"/>
@@ -13074,7 +13074,7 @@
                 <a:ea typeface="Consolas" pitchFamily="34" charset="-122"/>
                 <a:cs typeface="Consolas" pitchFamily="34" charset="-120"/>
               </a:rPr>
-              <a:t>$ python offline_demo/run_demo.py
+              <a:t>Gazebo X3 multicopter, 200 m tunnel flight
 </a:t>
             </a:r>
             <a:endParaRPr lang="en-US" sz="1000" dirty="0"/>
@@ -13095,7 +13095,7 @@
                 <a:ea typeface="Consolas" pitchFamily="34" charset="-122"/>
                 <a:cs typeface="Consolas" pitchFamily="34" charset="-120"/>
               </a:rPr>
-              <a:t>  IB coverage 100%  ·  detection 0.3 s  ·  5 figures
+              <a:t>  x→199.8 m · centered ±0.58 m · IMU alive (σ .287)
 </a:t>
             </a:r>
             <a:endParaRPr lang="en-US" sz="1000" dirty="0"/>
@@ -13116,7 +13116,7 @@
                 <a:ea typeface="Consolas" pitchFamily="34" charset="-122"/>
                 <a:cs typeface="Consolas" pitchFamily="34" charset="-120"/>
               </a:rPr>
-              <a:t>$ pytest offline_demo/test_core.py -q
+              <a:t>OpenVINS MSCKF on OUR sim (jazzy container)
 </a:t>
             </a:r>
             <a:endParaRPr lang="en-US" sz="1000" dirty="0"/>
@@ -13137,7 +13137,7 @@
                 <a:ea typeface="Consolas" pitchFamily="34" charset="-122"/>
                 <a:cs typeface="Consolas" pitchFamily="34" charset="-120"/>
               </a:rPr>
-              <a:t>  5 passed</a:t>
+              <a:t>  0.219% drift / 202 m — DP7 &lt;1.5% beaten 6.8×</a:t>
             </a:r>
             <a:endParaRPr lang="en-US" sz="1000" dirty="0"/>
           </a:p>
@@ -13176,7 +13176,7 @@
                 <a:ea typeface="Consolas" pitchFamily="34" charset="-122"/>
                 <a:cs typeface="Consolas" pitchFamily="34" charset="-120"/>
               </a:rPr>
-              <a:t>THE LIVE PATH (de-risked)</a:t>
+              <a:t>THE FULL CHAIN, END-TO-END</a:t>
             </a:r>
             <a:endParaRPr lang="en-US" sz="950" dirty="0"/>
           </a:p>
@@ -13218,7 +13218,7 @@
                 <a:ea typeface="Segoe UI" pitchFamily="34" charset="-122"/>
                 <a:cs typeface="Segoe UI" pitchFamily="34" charset="-120"/>
               </a:rPr>
-              <a:t>The ROS2 integrity_monitor reuses the SAME validated core: it reads pose+covariance on /ov_msckf/odomimu, extracts the 3×3 position block, computes the dual protection level + NEES + the NOMINAL→DEGRADED→INERTIAL→RE_ACQUIRE state machine, and publishes /nav/trust, /nav/integrity_bound, /nav/state. The RViz cockpit renders the breathing ellipse; /kill_camera injects the fault. ROS2/Gazebo build runs on Ubuntu (documented step-by-step in the manual).</a:t>
+              <a:t>Gazebo Harmonic renders the stereo tunnel flight (physics-real rotor forces, HG4930-class IMU); ros_gz records the golden bag; the pinned ros:jazzy container replays it through OpenVINS ov_msckf; eval/compute_drift.py (time-synced, SE(3)-aligned) scores it against simulator ground truth; and the SAME integrity nodes that run the live demo run against the real VIO output (docker compose run chain). CI rebuilds the whole workspace on ros:jazzy at every push.</a:t>
             </a:r>
             <a:endParaRPr lang="en-US" sz="1000" dirty="0"/>
           </a:p>
@@ -14078,7 +14078,7 @@
                           <a:ea typeface="Segoe UI" pitchFamily="34" charset="-122"/>
                           <a:cs typeface="Segoe UI" pitchFamily="34" charset="-120"/>
                         </a:rPr>
-                        <a:t>RIG RESULT</a:t>
+                        <a:t>MEASURED</a:t>
                       </a:r>
                       <a:endParaRPr lang="en-US" sz="950" dirty="0">
                         <a:latin typeface="Segoe UI" charset="0"/>
@@ -14216,7 +14216,7 @@
                           <a:ea typeface="Segoe UI" pitchFamily="34" charset="-122"/>
                           <a:cs typeface="Segoe UI" pitchFamily="34" charset="-120"/>
                         </a:rPr>
-                        <a:t>IB coverage @ k=2.45</a:t>
+                        <a:t>IB coverage @ k=2.45 (live ROS2)</a:t>
                       </a:r>
                       <a:endParaRPr lang="en-US" sz="950" dirty="0">
                         <a:latin typeface="Segoe UI" charset="0"/>
@@ -14352,7 +14352,7 @@
                           <a:ea typeface="Segoe UI" pitchFamily="34" charset="-122"/>
                           <a:cs typeface="Segoe UI" pitchFamily="34" charset="-120"/>
                         </a:rPr>
-                        <a:t>100%</a:t>
+                        <a:t>97.6% (emergent)</a:t>
                       </a:r>
                       <a:endParaRPr lang="en-US" sz="950" dirty="0">
                         <a:latin typeface="Segoe UI" charset="0"/>
@@ -14490,7 +14490,7 @@
                           <a:ea typeface="Segoe UI" pitchFamily="34" charset="-122"/>
                           <a:cs typeface="Segoe UI" pitchFamily="34" charset="-120"/>
                         </a:rPr>
-                        <a:t>fault-detection latency</a:t>
+                        <a:t>fault-detection latency (live ROS2)</a:t>
                       </a:r>
                       <a:endParaRPr lang="en-US" sz="950" dirty="0">
                         <a:latin typeface="Segoe UI" charset="0"/>
@@ -14558,7 +14558,7 @@
                           <a:ea typeface="Segoe UI" pitchFamily="34" charset="-122"/>
                           <a:cs typeface="Segoe UI" pitchFamily="34" charset="-120"/>
                         </a:rPr>
-                        <a:t>&lt; 0.5 s</a:t>
+                        <a:t>&lt; 1.5 s</a:t>
                       </a:r>
                       <a:endParaRPr lang="en-US" sz="950" dirty="0">
                         <a:latin typeface="Segoe UI" charset="0"/>
@@ -14626,7 +14626,7 @@
                           <a:ea typeface="Segoe UI" pitchFamily="34" charset="-122"/>
                           <a:cs typeface="Segoe UI" pitchFamily="34" charset="-120"/>
                         </a:rPr>
-                        <a:t>0.3 s</a:t>
+                        <a:t>1.18 s</a:t>
                       </a:r>
                       <a:endParaRPr lang="en-US" sz="950" dirty="0">
                         <a:latin typeface="Segoe UI" charset="0"/>
@@ -14756,7 +14756,7 @@
                         <a:buNone/>
                       </a:pPr>
                       <a:r>
-                        <a:rPr lang="en-US" sz="950" dirty="0">
+                        <a:rPr lang="en-US" sz="950" b="1" dirty="0">
                           <a:solidFill>
                             <a:srgbClr val="1B2A36"/>
                           </a:solidFill>
@@ -14764,7 +14764,7 @@
                           <a:ea typeface="Segoe UI" pitchFamily="34" charset="-122"/>
                           <a:cs typeface="Segoe UI" pitchFamily="34" charset="-120"/>
                         </a:rPr>
-                        <a:t>translational drift</a:t>
+                        <a:t>translational drift — OpenVINS on OUR Gazebo flight</a:t>
                       </a:r>
                       <a:endParaRPr lang="en-US" sz="950" dirty="0">
                         <a:latin typeface="Segoe UI" charset="0"/>
@@ -14892,15 +14892,15 @@
                         <a:buNone/>
                       </a:pPr>
                       <a:r>
-                        <a:rPr lang="en-US" sz="950" dirty="0">
+                        <a:rPr lang="en-US" sz="950" b="1" dirty="0">
                           <a:solidFill>
-                            <a:srgbClr val="1B2A36"/>
+                            <a:srgbClr val="2F7D4F"/>
                           </a:solidFill>
                           <a:latin typeface="Segoe UI" pitchFamily="34" charset="0"/>
                           <a:ea typeface="Segoe UI" pitchFamily="34" charset="-122"/>
                           <a:cs typeface="Segoe UI" pitchFamily="34" charset="-120"/>
                         </a:rPr>
-                        <a:t>under limit (target)</a:t>
+                        <a:t>0.219% / 202.2 m</a:t>
                       </a:r>
                       <a:endParaRPr lang="en-US" sz="950" dirty="0">
                         <a:latin typeface="Segoe UI" charset="0"/>
@@ -15038,7 +15038,7 @@
                           <a:ea typeface="Segoe UI" pitchFamily="34" charset="-122"/>
                           <a:cs typeface="Segoe UI" pitchFamily="34" charset="-120"/>
                         </a:rPr>
-                        <a:t>inertial-outage error (8 s)</a:t>
+                        <a:t>filter consistency (ANEES, live)</a:t>
                       </a:r>
                       <a:endParaRPr lang="en-US" sz="950" dirty="0">
                         <a:latin typeface="Segoe UI" charset="0"/>
@@ -15106,7 +15106,7 @@
                           <a:ea typeface="Segoe UI" pitchFamily="34" charset="-122"/>
                           <a:cs typeface="Segoe UI" pitchFamily="34" charset="-120"/>
                         </a:rPr>
-                        <a:t>≈ 0.4 m (HG4930)</a:t>
+                        <a:t>≈ 3 (χ²₃)</a:t>
                       </a:r>
                       <a:endParaRPr lang="en-US" sz="950" dirty="0">
                         <a:latin typeface="Segoe UI" charset="0"/>
@@ -15174,7 +15174,7 @@
                           <a:ea typeface="Segoe UI" pitchFamily="34" charset="-122"/>
                           <a:cs typeface="Segoe UI" pitchFamily="34" charset="-120"/>
                         </a:rPr>
-                        <a:t>matches physics ±20%</a:t>
+                        <a:t>3.05</a:t>
                       </a:r>
                       <a:endParaRPr lang="en-US" sz="950" dirty="0">
                         <a:latin typeface="Segoe UI" charset="0"/>
@@ -15242,7 +15242,7 @@
                           <a:ea typeface="Segoe UI" pitchFamily="34" charset="-122"/>
                           <a:cs typeface="Segoe UI" pitchFamily="34" charset="-120"/>
                         </a:rPr>
-                        <a:t>graceful degradation to INS</a:t>
+                        <a:t>honest covariance</a:t>
                       </a:r>
                       <a:endParaRPr lang="en-US" sz="950" dirty="0">
                         <a:latin typeface="Segoe UI" charset="0"/>

</xml_diff>